<commit_message>
Correct Kyrgyz prose in lesson decks and page text.
Decimals use a comma, thousands a narrow space, and multiple-choice
letters are А Б В Г. Solving a problem is «чыгар»; «чечет» and
«чечүүчү суроо» stay. File names are unchanged. The change log is
docs/kyrgyz-prose-changelog.csv, and migration 0055 applies the same
edit to decks already on the Railway volume.

Co-authored-by: Amanov <isaamanov@gmail.com>
</commit_message>
<xml_diff>
--- a/apps/resources/bundled_files/heuristics-PoliaOylonupChech.pptx
+++ b/apps/resources/bundled_files/heuristics-PoliaOylonupChech.pptx
@@ -518,7 +518,7 @@
           <a:lstStyle/>
           <a:p>
             <a:r>
-              <a:t>Ар бир маселени үн чыгарып ойлонуп чечиңиз. Окуучулардан «кайсы ыкма?» деп сураңыз.</a:t>
+              <a:t>Ар бир маселени үн чыгарып ойлонуп чыгарыңыз. Окуучулардан «кайсы ыкма?» деп сураңыз.</a:t>
             </a:r>
           </a:p>
         </p:txBody>
@@ -4125,7 +4125,7 @@
                 <a:ea typeface="IBM Plex Sans"/>
                 <a:cs typeface="IBM Plex Sans"/>
               </a:rPr>
-              <a:t>Маселе чечүү ыкмалары</a:t>
+              <a:t>Маселе чыгаруу ыкмалары</a:t>
             </a:r>
           </a:p>
         </p:txBody>
@@ -4163,7 +4163,7 @@
                 <a:ea typeface="IBM Plex Sans"/>
                 <a:cs typeface="IBM Plex Sans"/>
               </a:rPr>
-              <a:t>Полиа: ойлонуп чеч</a:t>
+              <a:t>Полиа: ойлонуп чыгар</a:t>
             </a:r>
           </a:p>
         </p:txBody>
@@ -4960,7 +4960,7 @@
                 <a:ea typeface="IBM Plex Sans"/>
                 <a:cs typeface="IBM Plex Sans"/>
               </a:rPr>
-              <a:t>Маселе чечүү ыкмалары</a:t>
+              <a:t>Маселе чыгаруу ыкмалары</a:t>
             </a:r>
           </a:p>
         </p:txBody>
@@ -5781,7 +5781,7 @@
                 <a:ea typeface="IBM Plex Sans"/>
                 <a:cs typeface="IBM Plex Sans"/>
               </a:rPr>
-              <a:t>Маселе чечүү ыкмалары</a:t>
+              <a:t>Маселе чыгаруу ыкмалары</a:t>
             </a:r>
           </a:p>
         </p:txBody>
@@ -7033,7 +7033,7 @@
                 <a:ea typeface="IBM Plex Sans"/>
                 <a:cs typeface="IBM Plex Sans"/>
               </a:rPr>
-              <a:t>Маселе чечүү ыкмалары</a:t>
+              <a:t>Маселе чыгаруу ыкмалары</a:t>
             </a:r>
           </a:p>
         </p:txBody>
@@ -8287,7 +8287,7 @@
                 <a:ea typeface="IBM Plex Sans"/>
                 <a:cs typeface="IBM Plex Sans"/>
               </a:rPr>
-              <a:t>Маселе чечүү ыкмалары</a:t>
+              <a:t>Маселе чыгаруу ыкмалары</a:t>
             </a:r>
           </a:p>
         </p:txBody>
@@ -9496,7 +9496,7 @@
                 <a:ea typeface="IBM Plex Sans"/>
                 <a:cs typeface="IBM Plex Sans"/>
               </a:rPr>
-              <a:t>Маселе чечүү ыкмалары</a:t>
+              <a:t>Маселе чыгаруу ыкмалары</a:t>
             </a:r>
           </a:p>
         </p:txBody>
@@ -10705,7 +10705,7 @@
                 <a:ea typeface="IBM Plex Sans"/>
                 <a:cs typeface="IBM Plex Sans"/>
               </a:rPr>
-              <a:t>Маселе чечүү ыкмалары</a:t>
+              <a:t>Маселе чыгаруу ыкмалары</a:t>
             </a:r>
           </a:p>
         </p:txBody>
@@ -11612,7 +11612,7 @@
                 <a:ea typeface="IBM Plex Sans"/>
                 <a:cs typeface="IBM Plex Sans"/>
               </a:rPr>
-              <a:t>Маселе чечүү ыкмалары</a:t>
+              <a:t>Маселе чыгаруу ыкмалары</a:t>
             </a:r>
           </a:p>
         </p:txBody>
@@ -12557,7 +12557,7 @@
                 <a:ea typeface="IBM Plex Sans"/>
                 <a:cs typeface="IBM Plex Sans"/>
               </a:rPr>
-              <a:t>Маселе чечүү ыкмалары</a:t>
+              <a:t>Маселе чыгаруу ыкмалары</a:t>
             </a:r>
           </a:p>
         </p:txBody>
@@ -13464,7 +13464,7 @@
                 <a:ea typeface="IBM Plex Sans"/>
                 <a:cs typeface="IBM Plex Sans"/>
               </a:rPr>
-              <a:t>Маселе чечүү ыкмалары</a:t>
+              <a:t>Маселе чыгаруу ыкмалары</a:t>
             </a:r>
           </a:p>
         </p:txBody>

</xml_diff>

<commit_message>
Correct Kyrgyz prose in materials and page text (#45)
Correct Kyrgyz prose in lesson decks and page text.

Decimals use a comma, thousands a narrow space, and multiple-choice
letters are А Б В Г. Solving a problem is «чыгар»; «чечет» and
«чечүүчү суроо» stay. File names are unchanged. The change log is
docs/kyrgyz-prose-changelog.csv, and migration 0055 applies the same
edit to decks already on the Railway volume.

Co-authored-by: Cursor Agent <cursoragent@cursor.com>
</commit_message>
<xml_diff>
--- a/apps/resources/bundled_files/heuristics-PoliaOylonupChech.pptx
+++ b/apps/resources/bundled_files/heuristics-PoliaOylonupChech.pptx
@@ -518,7 +518,7 @@
           <a:lstStyle/>
           <a:p>
             <a:r>
-              <a:t>Ар бир маселени үн чыгарып ойлонуп чечиңиз. Окуучулардан «кайсы ыкма?» деп сураңыз.</a:t>
+              <a:t>Ар бир маселени үн чыгарып ойлонуп чыгарыңыз. Окуучулардан «кайсы ыкма?» деп сураңыз.</a:t>
             </a:r>
           </a:p>
         </p:txBody>
@@ -4125,7 +4125,7 @@
                 <a:ea typeface="IBM Plex Sans"/>
                 <a:cs typeface="IBM Plex Sans"/>
               </a:rPr>
-              <a:t>Маселе чечүү ыкмалары</a:t>
+              <a:t>Маселе чыгаруу ыкмалары</a:t>
             </a:r>
           </a:p>
         </p:txBody>
@@ -4163,7 +4163,7 @@
                 <a:ea typeface="IBM Plex Sans"/>
                 <a:cs typeface="IBM Plex Sans"/>
               </a:rPr>
-              <a:t>Полиа: ойлонуп чеч</a:t>
+              <a:t>Полиа: ойлонуп чыгар</a:t>
             </a:r>
           </a:p>
         </p:txBody>
@@ -4960,7 +4960,7 @@
                 <a:ea typeface="IBM Plex Sans"/>
                 <a:cs typeface="IBM Plex Sans"/>
               </a:rPr>
-              <a:t>Маселе чечүү ыкмалары</a:t>
+              <a:t>Маселе чыгаруу ыкмалары</a:t>
             </a:r>
           </a:p>
         </p:txBody>
@@ -5781,7 +5781,7 @@
                 <a:ea typeface="IBM Plex Sans"/>
                 <a:cs typeface="IBM Plex Sans"/>
               </a:rPr>
-              <a:t>Маселе чечүү ыкмалары</a:t>
+              <a:t>Маселе чыгаруу ыкмалары</a:t>
             </a:r>
           </a:p>
         </p:txBody>
@@ -7033,7 +7033,7 @@
                 <a:ea typeface="IBM Plex Sans"/>
                 <a:cs typeface="IBM Plex Sans"/>
               </a:rPr>
-              <a:t>Маселе чечүү ыкмалары</a:t>
+              <a:t>Маселе чыгаруу ыкмалары</a:t>
             </a:r>
           </a:p>
         </p:txBody>
@@ -8287,7 +8287,7 @@
                 <a:ea typeface="IBM Plex Sans"/>
                 <a:cs typeface="IBM Plex Sans"/>
               </a:rPr>
-              <a:t>Маселе чечүү ыкмалары</a:t>
+              <a:t>Маселе чыгаруу ыкмалары</a:t>
             </a:r>
           </a:p>
         </p:txBody>
@@ -9496,7 +9496,7 @@
                 <a:ea typeface="IBM Plex Sans"/>
                 <a:cs typeface="IBM Plex Sans"/>
               </a:rPr>
-              <a:t>Маселе чечүү ыкмалары</a:t>
+              <a:t>Маселе чыгаруу ыкмалары</a:t>
             </a:r>
           </a:p>
         </p:txBody>
@@ -10705,7 +10705,7 @@
                 <a:ea typeface="IBM Plex Sans"/>
                 <a:cs typeface="IBM Plex Sans"/>
               </a:rPr>
-              <a:t>Маселе чечүү ыкмалары</a:t>
+              <a:t>Маселе чыгаруу ыкмалары</a:t>
             </a:r>
           </a:p>
         </p:txBody>
@@ -11612,7 +11612,7 @@
                 <a:ea typeface="IBM Plex Sans"/>
                 <a:cs typeface="IBM Plex Sans"/>
               </a:rPr>
-              <a:t>Маселе чечүү ыкмалары</a:t>
+              <a:t>Маселе чыгаруу ыкмалары</a:t>
             </a:r>
           </a:p>
         </p:txBody>
@@ -12557,7 +12557,7 @@
                 <a:ea typeface="IBM Plex Sans"/>
                 <a:cs typeface="IBM Plex Sans"/>
               </a:rPr>
-              <a:t>Маселе чечүү ыкмалары</a:t>
+              <a:t>Маселе чыгаруу ыкмалары</a:t>
             </a:r>
           </a:p>
         </p:txBody>
@@ -13464,7 +13464,7 @@
                 <a:ea typeface="IBM Plex Sans"/>
                 <a:cs typeface="IBM Plex Sans"/>
               </a:rPr>
-              <a:t>Маселе чечүү ыкмалары</a:t>
+              <a:t>Маселе чыгаруу ыкмалары</a:t>
             </a:r>
           </a:p>
         </p:txBody>

</xml_diff>